<commit_message>
Add 17:00 posting uplift estimate to 48h impressions chart
Co-Authored-By: Claude Opus 5.5 <noreply@anthropic.com>
Claude-Session: https://claude.ai/code/session_013dVRcgYhDnxS48iRzFXMsD
</commit_message>
<xml_diff>
--- a/OWV_リマインド・リポスト目標設計.pptx
+++ b/OWV_リマインド・リポスト目標設計.pptx
@@ -110,7 +110,7 @@
   <p:extLst>
     <p:ext uri="{521415D9-36F7-43E2-AB2F-B90AF26B5E84}">
       <p14:sectionLst xmlns:p14="http://schemas.microsoft.com/office/powerpoint/2010/main">
-        <p14:section name="OWV CP リマインド設計" id="{6d4d4044-e704-74b8-bfb2-659d3b5efa72}">
+        <p14:section name="OWV CP リマインド設計" id="{99e6fc45-0079-e9c9-aca9-c82862fdcb6f}">
           <p14:sldIdLst>
             <p14:sldId id="256"/>
             <p14:sldId id="257"/>
@@ -644,7 +644,7 @@
                 </a:solidFill>
                 <a:latin typeface="+mn-lt"/>
               </a:rPr>
-              <a:t>最初の48時間 インプレッション・累計割合</a:t>
+              <a:t>最初の48時間 1時間ごとのインプレッション（K）</a:t>
             </a:r>
           </a:p>
         </c:rich>
@@ -657,7 +657,7 @@
       <c:layout/>
       <c:barChart>
         <c:barDir val="col"/>
-        <c:grouping val="clustered"/>
+        <c:grouping val="stacked"/>
         <c:varyColors val="0"/>
         <c:ser>
           <c:idx val="0"/>
@@ -668,7 +668,7 @@
               <c:strCache>
                 <c:ptCount val="1"/>
                 <c:pt idx="0">
-                  <c:v>インプレッション（K）</c:v>
+                  <c:v>実績</c:v>
                 </c:pt>
               </c:strCache>
             </c:strRef>
@@ -1012,38 +1012,6 @@
             </c:numRef>
           </c:val>
         </c:ser>
-        <c:dLbls>
-          <c:numFmt formatCode="#,##0" sourceLinked="0"/>
-          <c:txPr>
-            <a:bodyPr/>
-            <a:lstStyle/>
-            <a:p>
-              <a:pPr>
-                <a:defRPr b="0" i="0" strike="noStrike" sz="1100" u="none">
-                  <a:solidFill>
-                    <a:srgbClr val="000000"/>
-                  </a:solidFill>
-                  <a:latin typeface="+mn-lt"/>
-                </a:defRPr>
-              </a:pPr>
-            </a:p>
-          </c:txPr>
-          <c:showLegendKey val="0"/>
-          <c:showVal val="0"/>
-          <c:showCatName val="0"/>
-          <c:showSerName val="0"/>
-          <c:showPercent val="0"/>
-          <c:showBubbleSize val="0"/>
-          <c:showLeaderLines val="0"/>
-        </c:dLbls>
-        <c:gapWidth val="30"/>
-        <c:overlap val="0"/>
-        <c:axId val="2094734554"/>
-        <c:axId val="2094734552"/>
-        <c:axId val="2094734556"/>
-      </c:barChart>
-      <c:lineChart>
-        <c:varyColors val="0"/>
         <c:ser>
           <c:idx val="1"/>
           <c:order val="1"/>
@@ -1053,7 +1021,7 @@
               <c:strCache>
                 <c:ptCount val="1"/>
                 <c:pt idx="0">
-                  <c:v>累計割合（%）</c:v>
+                  <c:v>17時投稿の上乗せ（想定）</c:v>
                 </c:pt>
               </c:strCache>
             </c:strRef>
@@ -1062,13 +1030,6 @@
             <a:solidFill>
               <a:srgbClr val="C8102E"/>
             </a:solidFill>
-            <a:ln w="31750" cap="flat">
-              <a:solidFill>
-                <a:srgbClr val="C8102E"/>
-              </a:solidFill>
-              <a:prstDash val="solid"/>
-              <a:round/>
-            </a:ln>
             <a:effectLst/>
           </c:spPr>
           <c:invertIfNegative val="0"/>
@@ -1096,23 +1057,6 @@
             <c:showBubbleSize val="0"/>
             <c:showLeaderLines val="0"/>
           </c:dLbls>
-          <c:marker>
-            <c:symbol val="none"/>
-            <c:size val="6"/>
-            <c:spPr>
-              <a:solidFill>
-                <a:srgbClr val="C8102E"/>
-              </a:solidFill>
-              <a:ln w="9525" cap="flat">
-                <a:solidFill>
-                  <a:srgbClr val="C8102E"/>
-                </a:solidFill>
-                <a:prstDash val="solid"/>
-                <a:round/>
-              </a:ln>
-              <a:effectLst/>
-            </c:spPr>
-          </c:marker>
           <c:cat>
             <c:multiLvlStrRef>
               <c:f>Sheet1!$A$2:$A$49</c:f>
@@ -1274,153 +1218,152 @@
                 <c:formatCode>General</c:formatCode>
                 <c:ptCount val="48"/>
                 <c:pt idx="0">
-                  <c:v>5</c:v>
+                  <c:v>0.69</c:v>
                 </c:pt>
                 <c:pt idx="1">
-                  <c:v>26</c:v>
+                  <c:v>2.68</c:v>
                 </c:pt>
                 <c:pt idx="2">
-                  <c:v>34</c:v>
+                  <c:v>1.1</c:v>
                 </c:pt>
                 <c:pt idx="3">
-                  <c:v>41</c:v>
+                  <c:v>0.89</c:v>
                 </c:pt>
                 <c:pt idx="4">
-                  <c:v>47</c:v>
+                  <c:v>0.79</c:v>
                 </c:pt>
                 <c:pt idx="5">
-                  <c:v>53</c:v>
+                  <c:v>0.72</c:v>
                 </c:pt>
                 <c:pt idx="6">
-                  <c:v>59</c:v>
+                  <c:v>0.72</c:v>
                 </c:pt>
                 <c:pt idx="7">
-                  <c:v>65</c:v>
+                  <c:v>0.82</c:v>
                 </c:pt>
                 <c:pt idx="8">
-                  <c:v>70</c:v>
+                  <c:v>0.69</c:v>
                 </c:pt>
                 <c:pt idx="9">
-                  <c:v>76</c:v>
+                  <c:v>0.79</c:v>
                 </c:pt>
                 <c:pt idx="10">
-                  <c:v>81</c:v>
+                  <c:v>0.58</c:v>
                 </c:pt>
                 <c:pt idx="11">
-                  <c:v>84</c:v>
+                  <c:v>0.41</c:v>
                 </c:pt>
                 <c:pt idx="12">
-                  <c:v>86</c:v>
+                  <c:v>0.27</c:v>
                 </c:pt>
                 <c:pt idx="13">
-                  <c:v>88</c:v>
+                  <c:v>0.21</c:v>
                 </c:pt>
                 <c:pt idx="14">
-                  <c:v>89</c:v>
+                  <c:v>0.14</c:v>
                 </c:pt>
                 <c:pt idx="15">
-                  <c:v>90</c:v>
+                  <c:v>0.1</c:v>
                 </c:pt>
                 <c:pt idx="16">
-                  <c:v>90</c:v>
+                  <c:v>0.08</c:v>
                 </c:pt>
                 <c:pt idx="17">
-                  <c:v>91</c:v>
+                  <c:v>0.07</c:v>
                 </c:pt>
                 <c:pt idx="18">
-                  <c:v>91</c:v>
+                  <c:v>0.07</c:v>
                 </c:pt>
                 <c:pt idx="19">
-                  <c:v>92</c:v>
+                  <c:v>0.07</c:v>
                 </c:pt>
                 <c:pt idx="20">
-                  <c:v>92</c:v>
+                  <c:v>0.07</c:v>
                 </c:pt>
                 <c:pt idx="21">
-                  <c:v>93</c:v>
+                  <c:v>0.07</c:v>
                 </c:pt>
                 <c:pt idx="22">
-                  <c:v>93</c:v>
+                  <c:v>0.07</c:v>
                 </c:pt>
                 <c:pt idx="23">
-                  <c:v>94</c:v>
+                  <c:v>0.07</c:v>
                 </c:pt>
                 <c:pt idx="24">
-                  <c:v>95</c:v>
+                  <c:v>0.08</c:v>
                 </c:pt>
                 <c:pt idx="25">
-                  <c:v>95</c:v>
+                  <c:v>0.07</c:v>
                 </c:pt>
                 <c:pt idx="26">
-                  <c:v>96</c:v>
+                  <c:v>0.05</c:v>
                 </c:pt>
                 <c:pt idx="27">
-                  <c:v>96</c:v>
+                  <c:v>0.05</c:v>
                 </c:pt>
                 <c:pt idx="28">
-                  <c:v>96</c:v>
+                  <c:v>0.04</c:v>
                 </c:pt>
                 <c:pt idx="29">
-                  <c:v>97</c:v>
+                  <c:v>0.04</c:v>
                 </c:pt>
                 <c:pt idx="30">
-                  <c:v>97</c:v>
+                  <c:v>0.04</c:v>
                 </c:pt>
                 <c:pt idx="31">
-                  <c:v>97</c:v>
+                  <c:v>0.04</c:v>
                 </c:pt>
                 <c:pt idx="32">
-                  <c:v>98</c:v>
+                  <c:v>0.03</c:v>
                 </c:pt>
                 <c:pt idx="33">
-                  <c:v>98</c:v>
+                  <c:v>0.03</c:v>
                 </c:pt>
                 <c:pt idx="34">
-                  <c:v>98</c:v>
+                  <c:v>0.03</c:v>
                 </c:pt>
                 <c:pt idx="35">
-                  <c:v>98</c:v>
+                  <c:v>0.04</c:v>
                 </c:pt>
                 <c:pt idx="36">
-                  <c:v>99</c:v>
+                  <c:v>0.03</c:v>
                 </c:pt>
                 <c:pt idx="37">
-                  <c:v>99</c:v>
+                  <c:v>0.03</c:v>
                 </c:pt>
                 <c:pt idx="38">
-                  <c:v>99</c:v>
+                  <c:v>0.02</c:v>
                 </c:pt>
                 <c:pt idx="39">
-                  <c:v>99</c:v>
+                  <c:v>0.02</c:v>
                 </c:pt>
                 <c:pt idx="40">
-                  <c:v>99</c:v>
+                  <c:v>0.01</c:v>
                 </c:pt>
                 <c:pt idx="41">
-                  <c:v>99</c:v>
+                  <c:v>0.01</c:v>
                 </c:pt>
                 <c:pt idx="42">
-                  <c:v>99</c:v>
+                  <c:v>0.01</c:v>
                 </c:pt>
                 <c:pt idx="43">
-                  <c:v>100</c:v>
+                  <c:v>0.01</c:v>
                 </c:pt>
                 <c:pt idx="44">
-                  <c:v>100</c:v>
+                  <c:v>0.01</c:v>
                 </c:pt>
                 <c:pt idx="45">
-                  <c:v>100</c:v>
+                  <c:v>0.01</c:v>
                 </c:pt>
                 <c:pt idx="46">
-                  <c:v>100</c:v>
+                  <c:v>0.01</c:v>
                 </c:pt>
                 <c:pt idx="47">
-                  <c:v>100</c:v>
+                  <c:v>0.01</c:v>
                 </c:pt>
               </c:numCache>
             </c:numRef>
           </c:val>
-          <c:smooth val="0"/>
         </c:ser>
         <c:dLbls>
           <c:numFmt formatCode="#,##0" sourceLinked="0"/>
@@ -1446,11 +1389,12 @@
           <c:showBubbleSize val="0"/>
           <c:showLeaderLines val="0"/>
         </c:dLbls>
-        <c:marker val="1"/>
-        <c:axId val="2094734555"/>
-        <c:axId val="2094734553"/>
+        <c:gapWidth val="30"/>
+        <c:overlap val="100"/>
+        <c:axId val="2094734554"/>
+        <c:axId val="2094734552"/>
         <c:axId val="2094734556"/>
-      </c:lineChart>
+      </c:barChart>
       <c:catAx>
         <c:axId val="2094734554"/>
         <c:scaling>
@@ -1497,7 +1441,7 @@
         <c:axId val="2094734552"/>
         <c:scaling>
           <c:orientation val="minMax"/>
-          <c:max val="4"/>
+          <c:max val="7"/>
           <c:min val="0"/>
         </c:scaling>
         <c:delete val="0"/>
@@ -1546,89 +1490,6 @@
         <c:crossBetween val="between"/>
         <c:majorUnit val="1"/>
       </c:valAx>
-      <c:valAx>
-        <c:axId val="2094734553"/>
-        <c:scaling>
-          <c:orientation val="minMax"/>
-          <c:max val="100"/>
-          <c:min val="0"/>
-        </c:scaling>
-        <c:delete val="0"/>
-        <c:axPos val="r"/>
-        <c:numFmt formatCode="General" sourceLinked="0"/>
-        <c:majorTickMark val="out"/>
-        <c:minorTickMark val="none"/>
-        <c:tickLblPos val="nextTo"/>
-        <c:spPr>
-          <a:ln w="12700" cap="flat">
-            <a:solidFill>
-              <a:srgbClr val="888888"/>
-            </a:solidFill>
-            <a:prstDash val="solid"/>
-            <a:round/>
-          </a:ln>
-        </c:spPr>
-        <c:txPr>
-          <a:bodyPr/>
-          <a:lstStyle/>
-          <a:p>
-            <a:pPr>
-              <a:defRPr sz="1000" b="0" i="0" u="none" strike="noStrike">
-                <a:solidFill>
-                  <a:srgbClr val="C8102E"/>
-                </a:solidFill>
-                <a:latin typeface="+mn-lt"/>
-              </a:defRPr>
-            </a:pPr>
-            <a:endParaRPr lang="en-US"/>
-          </a:p>
-        </c:txPr>
-        <c:crossAx val="2094734555"/>
-        <c:crosses val="max"/>
-        <c:crossBetween val="between"/>
-        <c:majorUnit val="25"/>
-      </c:valAx>
-      <c:catAx>
-        <c:axId val="2094734555"/>
-        <c:scaling>
-          <c:orientation val="minMax"/>
-        </c:scaling>
-        <c:delete val="1"/>
-        <c:axPos val="b"/>
-        <c:numFmt formatCode="General" sourceLinked="1"/>
-        <c:majorTickMark val="out"/>
-        <c:minorTickMark val="none"/>
-        <c:tickLblPos val="low"/>
-        <c:spPr>
-          <a:ln w="12700" cap="flat">
-            <a:solidFill>
-              <a:srgbClr val="888888"/>
-            </a:solidFill>
-            <a:prstDash val="solid"/>
-            <a:round/>
-          </a:ln>
-        </c:spPr>
-        <c:txPr>
-          <a:bodyPr/>
-          <a:lstStyle/>
-          <a:p>
-            <a:pPr>
-              <a:defRPr sz="1100" b="0" i="0" u="none" strike="noStrike">
-                <a:solidFill>
-                  <a:srgbClr val="404040"/>
-                </a:solidFill>
-                <a:latin typeface="+mn-lt"/>
-              </a:defRPr>
-            </a:pPr>
-            <a:endParaRPr lang="en-US"/>
-          </a:p>
-        </c:txPr>
-        <c:crossAx val="2094734553"/>
-        <c:crosses val="autoZero"/>
-        <c:auto val="1"/>
-        <c:lblAlgn val="ctr"/>
-        <c:noMultiLvlLbl val="1"/>
-      </c:catAx>
       <c:spPr>
         <a:noFill/>
         <a:ln>
@@ -5484,7 +5345,74 @@
       </p:graphicFrame>
       <p:sp>
         <p:nvSpPr>
-          <p:cNvPr id="7" name="Text 3"/>
+          <p:cNvPr id="7" name="uplift-callout"/>
+          <p:cNvSpPr txBox="1"/>
+          <p:nvPr/>
+        </p:nvSpPr>
+        <p:spPr>
+          <a:xfrm>
+            <a:off x="8412480" y="3429000"/>
+            <a:ext cx="3200400" cy="548640"/>
+          </a:xfrm>
+          <a:prstGeom prst="rect">
+            <a:avLst/>
+          </a:prstGeom>
+          <a:solidFill>
+            <a:srgbClr val="FFFFFF"/>
+          </a:solidFill>
+          <a:ln w="9525">
+            <a:solidFill>
+              <a:srgbClr val="D9D9D9"/>
+            </a:solidFill>
+          </a:ln>
+        </p:spPr>
+        <p:txBody>
+          <a:bodyPr wrap="square" lIns="25400" tIns="76200" rIns="76200" bIns="25400" rtlCol="0" anchor="ctr"/>
+          <a:lstStyle/>
+          <a:p>
+            <a:pPr indent="0" marL="0">
+              <a:buNone/>
+            </a:pPr>
+            <a:r>
+              <a:rPr lang="en-US" sz="1000" dirty="0">
+                <a:solidFill>
+                  <a:srgbClr val="404040"/>
+                </a:solidFill>
+              </a:rPr>
+              <a:t>48時間合計（概算）</a:t>
+            </a:r>
+            <a:endParaRPr lang="en-US" sz="1000" dirty="0"/>
+          </a:p>
+          <a:p>
+            <a:pPr indent="0" marL="0">
+              <a:buNone/>
+            </a:pPr>
+            <a:r>
+              <a:rPr lang="en-US" sz="1200" dirty="0">
+                <a:solidFill>
+                  <a:srgbClr val="222222"/>
+                </a:solidFill>
+              </a:rPr>
+              <a:t>実績 18.9K → </a:t>
+            </a:r>
+            <a:pPr indent="0" marL="0">
+              <a:buNone/>
+            </a:pPr>
+            <a:r>
+              <a:rPr lang="en-US" sz="1200" b="1" dirty="0">
+                <a:solidFill>
+                  <a:srgbClr val="C8102E"/>
+                </a:solidFill>
+              </a:rPr>
+              <a:t>31.8K（約1.7倍）</a:t>
+            </a:r>
+            <a:endParaRPr lang="en-US" sz="1000" dirty="0"/>
+          </a:p>
+        </p:txBody>
+      </p:sp>
+      <p:sp>
+        <p:nvSpPr>
+          <p:cNvPr id="8" name="Text 4"/>
           <p:cNvSpPr txBox="1"/>
           <p:nvPr/>
         </p:nvSpPr>
@@ -5512,7 +5440,7 @@
                   <a:srgbClr val="7F7F7F"/>
                 </a:solidFill>
               </a:rPr>
-              <a:t>※日別・時間別の値はXアナリティクスのグラフからの目視読み取りによる概算（10/14はツールチップ実数）。10/23はイベント動画投稿、10/26はリマインド＋本家グッズアカウントRP</a:t>
+              <a:t>※値はXアナリティクスのグラフ目視読み取りの概算。17時投稿の想定は、実績を12-14時台投稿と仮定し、競合調査の平均ビュー比（15-17時台÷12-14時台＝1.69倍）で換算</a:t>
             </a:r>
             <a:endParaRPr lang="en-US" sz="1000" dirty="0"/>
           </a:p>

</xml_diff>

<commit_message>
Restore cumulative share line on 48h impressions chart
Co-Authored-By: Claude Opus 5.5 <noreply@anthropic.com>
Claude-Session: https://claude.ai/code/session_013dVRcgYhDnxS48iRzFXMsD
</commit_message>
<xml_diff>
--- a/OWV_リマインド・リポスト目標設計.pptx
+++ b/OWV_リマインド・リポスト目標設計.pptx
@@ -110,7 +110,7 @@
   <p:extLst>
     <p:ext uri="{521415D9-36F7-43E2-AB2F-B90AF26B5E84}">
       <p14:sectionLst xmlns:p14="http://schemas.microsoft.com/office/powerpoint/2010/main">
-        <p14:section name="OWV CP リマインド設計" id="{99e6fc45-0079-e9c9-aca9-c82862fdcb6f}">
+        <p14:section name="OWV CP リマインド設計" id="{34a514e6-1b76-8762-a47e-18358f3372b0}">
           <p14:sldIdLst>
             <p14:sldId id="256"/>
             <p14:sldId id="257"/>
@@ -644,7 +644,7 @@
                 </a:solidFill>
                 <a:latin typeface="+mn-lt"/>
               </a:rPr>
-              <a:t>最初の48時間 1時間ごとのインプレッション（K）</a:t>
+              <a:t>最初の48時間 インプレッション（K）と累計割合</a:t>
             </a:r>
           </a:p>
         </c:rich>
@@ -1395,6 +1395,415 @@
         <c:axId val="2094734552"/>
         <c:axId val="2094734556"/>
       </c:barChart>
+      <c:lineChart>
+        <c:varyColors val="0"/>
+        <c:ser>
+          <c:idx val="2"/>
+          <c:order val="2"/>
+          <c:tx>
+            <c:strRef>
+              <c:f>Sheet1!$D$1</c:f>
+              <c:strCache>
+                <c:ptCount val="1"/>
+                <c:pt idx="0">
+                  <c:v>累計割合（%）</c:v>
+                </c:pt>
+              </c:strCache>
+            </c:strRef>
+          </c:tx>
+          <c:spPr>
+            <a:solidFill>
+              <a:srgbClr val="E89A2C"/>
+            </a:solidFill>
+            <a:ln w="31750" cap="flat">
+              <a:solidFill>
+                <a:srgbClr val="E89A2C"/>
+              </a:solidFill>
+              <a:prstDash val="solid"/>
+              <a:round/>
+            </a:ln>
+            <a:effectLst/>
+          </c:spPr>
+          <c:invertIfNegative val="0"/>
+          <c:dLbls>
+            <c:numFmt formatCode="#,##0" sourceLinked="0"/>
+            <c:txPr>
+              <a:bodyPr/>
+              <a:lstStyle/>
+              <a:p>
+                <a:pPr>
+                  <a:defRPr b="0" i="0" strike="noStrike" sz="1100" u="none">
+                    <a:solidFill>
+                      <a:srgbClr val="000000"/>
+                    </a:solidFill>
+                    <a:latin typeface="+mn-lt"/>
+                  </a:defRPr>
+                </a:pPr>
+              </a:p>
+            </c:txPr>
+            <c:showLegendKey val="0"/>
+            <c:showVal val="0"/>
+            <c:showCatName val="0"/>
+            <c:showSerName val="0"/>
+            <c:showPercent val="0"/>
+            <c:showBubbleSize val="0"/>
+            <c:showLeaderLines val="0"/>
+          </c:dLbls>
+          <c:marker>
+            <c:symbol val="none"/>
+            <c:size val="6"/>
+            <c:spPr>
+              <a:solidFill>
+                <a:srgbClr val="E89A2C"/>
+              </a:solidFill>
+              <a:ln w="9525" cap="flat">
+                <a:solidFill>
+                  <a:srgbClr val="E89A2C"/>
+                </a:solidFill>
+                <a:prstDash val="solid"/>
+                <a:round/>
+              </a:ln>
+              <a:effectLst/>
+            </c:spPr>
+          </c:marker>
+          <c:cat>
+            <c:multiLvlStrRef>
+              <c:f>Sheet1!$A$2:$A$49</c:f>
+              <c:multiLvlStrCache>
+                <c:ptCount val="48"/>
+                <c:lvl>
+                  <c:pt idx="0">
+                    <c:v>0h</c:v>
+                  </c:pt>
+                  <c:pt idx="1">
+                    <c:v>1h</c:v>
+                  </c:pt>
+                  <c:pt idx="2">
+                    <c:v>2h</c:v>
+                  </c:pt>
+                  <c:pt idx="3">
+                    <c:v>3h</c:v>
+                  </c:pt>
+                  <c:pt idx="4">
+                    <c:v>4h</c:v>
+                  </c:pt>
+                  <c:pt idx="5">
+                    <c:v>5h</c:v>
+                  </c:pt>
+                  <c:pt idx="6">
+                    <c:v>6h</c:v>
+                  </c:pt>
+                  <c:pt idx="7">
+                    <c:v>7h</c:v>
+                  </c:pt>
+                  <c:pt idx="8">
+                    <c:v>8h</c:v>
+                  </c:pt>
+                  <c:pt idx="9">
+                    <c:v>9h</c:v>
+                  </c:pt>
+                  <c:pt idx="10">
+                    <c:v>10h</c:v>
+                  </c:pt>
+                  <c:pt idx="11">
+                    <c:v>11h</c:v>
+                  </c:pt>
+                  <c:pt idx="12">
+                    <c:v>12h</c:v>
+                  </c:pt>
+                  <c:pt idx="13">
+                    <c:v>13h</c:v>
+                  </c:pt>
+                  <c:pt idx="14">
+                    <c:v>14h</c:v>
+                  </c:pt>
+                  <c:pt idx="15">
+                    <c:v>15h</c:v>
+                  </c:pt>
+                  <c:pt idx="16">
+                    <c:v>16h</c:v>
+                  </c:pt>
+                  <c:pt idx="17">
+                    <c:v>17h</c:v>
+                  </c:pt>
+                  <c:pt idx="18">
+                    <c:v>18h</c:v>
+                  </c:pt>
+                  <c:pt idx="19">
+                    <c:v>19h</c:v>
+                  </c:pt>
+                  <c:pt idx="20">
+                    <c:v>20h</c:v>
+                  </c:pt>
+                  <c:pt idx="21">
+                    <c:v>21h</c:v>
+                  </c:pt>
+                  <c:pt idx="22">
+                    <c:v>22h</c:v>
+                  </c:pt>
+                  <c:pt idx="23">
+                    <c:v>23h</c:v>
+                  </c:pt>
+                  <c:pt idx="24">
+                    <c:v>24h</c:v>
+                  </c:pt>
+                  <c:pt idx="25">
+                    <c:v>25h</c:v>
+                  </c:pt>
+                  <c:pt idx="26">
+                    <c:v>26h</c:v>
+                  </c:pt>
+                  <c:pt idx="27">
+                    <c:v>27h</c:v>
+                  </c:pt>
+                  <c:pt idx="28">
+                    <c:v>28h</c:v>
+                  </c:pt>
+                  <c:pt idx="29">
+                    <c:v>29h</c:v>
+                  </c:pt>
+                  <c:pt idx="30">
+                    <c:v>30h</c:v>
+                  </c:pt>
+                  <c:pt idx="31">
+                    <c:v>31h</c:v>
+                  </c:pt>
+                  <c:pt idx="32">
+                    <c:v>32h</c:v>
+                  </c:pt>
+                  <c:pt idx="33">
+                    <c:v>33h</c:v>
+                  </c:pt>
+                  <c:pt idx="34">
+                    <c:v>34h</c:v>
+                  </c:pt>
+                  <c:pt idx="35">
+                    <c:v>35h</c:v>
+                  </c:pt>
+                  <c:pt idx="36">
+                    <c:v>36h</c:v>
+                  </c:pt>
+                  <c:pt idx="37">
+                    <c:v>37h</c:v>
+                  </c:pt>
+                  <c:pt idx="38">
+                    <c:v>38h</c:v>
+                  </c:pt>
+                  <c:pt idx="39">
+                    <c:v>39h</c:v>
+                  </c:pt>
+                  <c:pt idx="40">
+                    <c:v>40h</c:v>
+                  </c:pt>
+                  <c:pt idx="41">
+                    <c:v>41h</c:v>
+                  </c:pt>
+                  <c:pt idx="42">
+                    <c:v>42h</c:v>
+                  </c:pt>
+                  <c:pt idx="43">
+                    <c:v>43h</c:v>
+                  </c:pt>
+                  <c:pt idx="44">
+                    <c:v>44h</c:v>
+                  </c:pt>
+                  <c:pt idx="45">
+                    <c:v>45h</c:v>
+                  </c:pt>
+                  <c:pt idx="46">
+                    <c:v>46h</c:v>
+                  </c:pt>
+                  <c:pt idx="47">
+                    <c:v>47h</c:v>
+                  </c:pt>
+                </c:lvl>
+              </c:multiLvlStrCache>
+            </c:multiLvlStrRef>
+          </c:cat>
+          <c:val>
+            <c:numRef>
+              <c:f>Sheet1!$D$2:$D$49</c:f>
+              <c:numCache>
+                <c:formatCode>General</c:formatCode>
+                <c:ptCount val="48"/>
+                <c:pt idx="0">
+                  <c:v>5</c:v>
+                </c:pt>
+                <c:pt idx="1">
+                  <c:v>26</c:v>
+                </c:pt>
+                <c:pt idx="2">
+                  <c:v>34</c:v>
+                </c:pt>
+                <c:pt idx="3">
+                  <c:v>41</c:v>
+                </c:pt>
+                <c:pt idx="4">
+                  <c:v>47</c:v>
+                </c:pt>
+                <c:pt idx="5">
+                  <c:v>53</c:v>
+                </c:pt>
+                <c:pt idx="6">
+                  <c:v>59</c:v>
+                </c:pt>
+                <c:pt idx="7">
+                  <c:v>65</c:v>
+                </c:pt>
+                <c:pt idx="8">
+                  <c:v>70</c:v>
+                </c:pt>
+                <c:pt idx="9">
+                  <c:v>76</c:v>
+                </c:pt>
+                <c:pt idx="10">
+                  <c:v>81</c:v>
+                </c:pt>
+                <c:pt idx="11">
+                  <c:v>84</c:v>
+                </c:pt>
+                <c:pt idx="12">
+                  <c:v>86</c:v>
+                </c:pt>
+                <c:pt idx="13">
+                  <c:v>88</c:v>
+                </c:pt>
+                <c:pt idx="14">
+                  <c:v>89</c:v>
+                </c:pt>
+                <c:pt idx="15">
+                  <c:v>90</c:v>
+                </c:pt>
+                <c:pt idx="16">
+                  <c:v>90</c:v>
+                </c:pt>
+                <c:pt idx="17">
+                  <c:v>91</c:v>
+                </c:pt>
+                <c:pt idx="18">
+                  <c:v>91</c:v>
+                </c:pt>
+                <c:pt idx="19">
+                  <c:v>92</c:v>
+                </c:pt>
+                <c:pt idx="20">
+                  <c:v>92</c:v>
+                </c:pt>
+                <c:pt idx="21">
+                  <c:v>93</c:v>
+                </c:pt>
+                <c:pt idx="22">
+                  <c:v>93</c:v>
+                </c:pt>
+                <c:pt idx="23">
+                  <c:v>94</c:v>
+                </c:pt>
+                <c:pt idx="24">
+                  <c:v>95</c:v>
+                </c:pt>
+                <c:pt idx="25">
+                  <c:v>95</c:v>
+                </c:pt>
+                <c:pt idx="26">
+                  <c:v>96</c:v>
+                </c:pt>
+                <c:pt idx="27">
+                  <c:v>96</c:v>
+                </c:pt>
+                <c:pt idx="28">
+                  <c:v>96</c:v>
+                </c:pt>
+                <c:pt idx="29">
+                  <c:v>97</c:v>
+                </c:pt>
+                <c:pt idx="30">
+                  <c:v>97</c:v>
+                </c:pt>
+                <c:pt idx="31">
+                  <c:v>97</c:v>
+                </c:pt>
+                <c:pt idx="32">
+                  <c:v>98</c:v>
+                </c:pt>
+                <c:pt idx="33">
+                  <c:v>98</c:v>
+                </c:pt>
+                <c:pt idx="34">
+                  <c:v>98</c:v>
+                </c:pt>
+                <c:pt idx="35">
+                  <c:v>98</c:v>
+                </c:pt>
+                <c:pt idx="36">
+                  <c:v>99</c:v>
+                </c:pt>
+                <c:pt idx="37">
+                  <c:v>99</c:v>
+                </c:pt>
+                <c:pt idx="38">
+                  <c:v>99</c:v>
+                </c:pt>
+                <c:pt idx="39">
+                  <c:v>99</c:v>
+                </c:pt>
+                <c:pt idx="40">
+                  <c:v>99</c:v>
+                </c:pt>
+                <c:pt idx="41">
+                  <c:v>99</c:v>
+                </c:pt>
+                <c:pt idx="42">
+                  <c:v>99</c:v>
+                </c:pt>
+                <c:pt idx="43">
+                  <c:v>100</c:v>
+                </c:pt>
+                <c:pt idx="44">
+                  <c:v>100</c:v>
+                </c:pt>
+                <c:pt idx="45">
+                  <c:v>100</c:v>
+                </c:pt>
+                <c:pt idx="46">
+                  <c:v>100</c:v>
+                </c:pt>
+                <c:pt idx="47">
+                  <c:v>100</c:v>
+                </c:pt>
+              </c:numCache>
+            </c:numRef>
+          </c:val>
+          <c:smooth val="0"/>
+        </c:ser>
+        <c:dLbls>
+          <c:numFmt formatCode="#,##0" sourceLinked="0"/>
+          <c:txPr>
+            <a:bodyPr/>
+            <a:lstStyle/>
+            <a:p>
+              <a:pPr>
+                <a:defRPr b="0" i="0" strike="noStrike" sz="1100" u="none">
+                  <a:solidFill>
+                    <a:srgbClr val="000000"/>
+                  </a:solidFill>
+                  <a:latin typeface="+mn-lt"/>
+                </a:defRPr>
+              </a:pPr>
+            </a:p>
+          </c:txPr>
+          <c:showLegendKey val="0"/>
+          <c:showVal val="0"/>
+          <c:showCatName val="0"/>
+          <c:showSerName val="0"/>
+          <c:showPercent val="0"/>
+          <c:showBubbleSize val="0"/>
+          <c:showLeaderLines val="0"/>
+        </c:dLbls>
+        <c:marker val="1"/>
+        <c:axId val="2094734555"/>
+        <c:axId val="2094734553"/>
+        <c:axId val="2094734556"/>
+      </c:lineChart>
       <c:catAx>
         <c:axId val="2094734554"/>
         <c:scaling>
@@ -1490,6 +1899,89 @@
         <c:crossBetween val="between"/>
         <c:majorUnit val="1"/>
       </c:valAx>
+      <c:valAx>
+        <c:axId val="2094734553"/>
+        <c:scaling>
+          <c:orientation val="minMax"/>
+          <c:max val="100"/>
+          <c:min val="0"/>
+        </c:scaling>
+        <c:delete val="0"/>
+        <c:axPos val="r"/>
+        <c:numFmt formatCode="General" sourceLinked="0"/>
+        <c:majorTickMark val="out"/>
+        <c:minorTickMark val="none"/>
+        <c:tickLblPos val="nextTo"/>
+        <c:spPr>
+          <a:ln w="12700" cap="flat">
+            <a:solidFill>
+              <a:srgbClr val="888888"/>
+            </a:solidFill>
+            <a:prstDash val="solid"/>
+            <a:round/>
+          </a:ln>
+        </c:spPr>
+        <c:txPr>
+          <a:bodyPr/>
+          <a:lstStyle/>
+          <a:p>
+            <a:pPr>
+              <a:defRPr sz="1000" b="0" i="0" u="none" strike="noStrike">
+                <a:solidFill>
+                  <a:srgbClr val="C0761A"/>
+                </a:solidFill>
+                <a:latin typeface="+mn-lt"/>
+              </a:defRPr>
+            </a:pPr>
+            <a:endParaRPr lang="en-US"/>
+          </a:p>
+        </c:txPr>
+        <c:crossAx val="2094734555"/>
+        <c:crosses val="max"/>
+        <c:crossBetween val="between"/>
+        <c:majorUnit val="25"/>
+      </c:valAx>
+      <c:catAx>
+        <c:axId val="2094734555"/>
+        <c:scaling>
+          <c:orientation val="minMax"/>
+        </c:scaling>
+        <c:delete val="1"/>
+        <c:axPos val="b"/>
+        <c:numFmt formatCode="General" sourceLinked="1"/>
+        <c:majorTickMark val="out"/>
+        <c:minorTickMark val="none"/>
+        <c:tickLblPos val="low"/>
+        <c:spPr>
+          <a:ln w="12700" cap="flat">
+            <a:solidFill>
+              <a:srgbClr val="888888"/>
+            </a:solidFill>
+            <a:prstDash val="solid"/>
+            <a:round/>
+          </a:ln>
+        </c:spPr>
+        <c:txPr>
+          <a:bodyPr/>
+          <a:lstStyle/>
+          <a:p>
+            <a:pPr>
+              <a:defRPr sz="1100" b="0" i="0" u="none" strike="noStrike">
+                <a:solidFill>
+                  <a:srgbClr val="404040"/>
+                </a:solidFill>
+                <a:latin typeface="+mn-lt"/>
+              </a:defRPr>
+            </a:pPr>
+            <a:endParaRPr lang="en-US"/>
+          </a:p>
+        </c:txPr>
+        <c:crossAx val="2094734553"/>
+        <c:crosses val="autoZero"/>
+        <c:auto val="1"/>
+        <c:lblAlgn val="ctr"/>
+        <c:noMultiLvlLbl val="1"/>
+      </c:catAx>
       <c:spPr>
         <a:noFill/>
         <a:ln>
@@ -1506,7 +1998,7 @@
         <a:lstStyle/>
         <a:p>
           <a:pPr>
-            <a:defRPr sz="1100">
+            <a:defRPr sz="1000">
               <a:latin typeface="+mn-lt"/>
               <a:cs typeface="+mn-lt"/>
             </a:defRPr>
@@ -5351,8 +5843,8 @@
         </p:nvSpPr>
         <p:spPr>
           <a:xfrm>
-            <a:off x="8412480" y="3429000"/>
-            <a:ext cx="3200400" cy="548640"/>
+            <a:off x="8229600" y="4617720"/>
+            <a:ext cx="3017520" cy="548640"/>
           </a:xfrm>
           <a:prstGeom prst="rect">
             <a:avLst/>
@@ -5440,7 +5932,7 @@
                   <a:srgbClr val="7F7F7F"/>
                 </a:solidFill>
               </a:rPr>
-              <a:t>※値はXアナリティクスのグラフ目視読み取りの概算。17時投稿の想定は、実績を12-14時台投稿と仮定し、競合調査の平均ビュー比（15-17時台÷12-14時台＝1.69倍）で換算</a:t>
+              <a:t>※値はグラフ目視読み取りの概算。17時投稿の想定：実績を12-14時台投稿と仮定し、競合調査の平均ビュー比1.69倍（15-17時台÷12-14時台）で換算</a:t>
             </a:r>
             <a:endParaRPr lang="en-US" sz="1000" dirty="0"/>
           </a:p>

</xml_diff>

<commit_message>
Move all OWV campaign posts to weekdays
Co-Authored-By: Claude Opus 5.5 <noreply@anthropic.com>
Claude-Session: https://claude.ai/code/session_013dVRcgYhDnxS48iRzFXMsD
</commit_message>
<xml_diff>
--- a/OWV_リマインド・リポスト目標設計.pptx
+++ b/OWV_リマインド・リポスト目標設計.pptx
@@ -111,7 +111,7 @@
   <p:extLst>
     <p:ext uri="{521415D9-36F7-43E2-AB2F-B90AF26B5E84}">
       <p14:sectionLst xmlns:p14="http://schemas.microsoft.com/office/powerpoint/2010/main">
-        <p14:section name="OWV CP リマインド設計" id="{1ce354cd-c976-dfff-a999-663c8ae2090b}">
+        <p14:section name="OWV CP リマインド設計" id="{ce09c10c-051d-5fd0-61e6-5a08d682826d}">
           <p14:sldIdLst>
             <p14:sldId id="256"/>
             <p14:sldId id="257"/>
@@ -2795,10 +2795,10 @@
                   <c:v>0</c:v>
                 </c:pt>
                 <c:pt idx="7">
+                  <c:v>0</c:v>
+                </c:pt>
+                <c:pt idx="8">
                   <c:v>91</c:v>
-                </c:pt>
-                <c:pt idx="8">
-                  <c:v>0</c:v>
                 </c:pt>
                 <c:pt idx="9">
                   <c:v>0</c:v>
@@ -2813,10 +2813,10 @@
                   <c:v>0</c:v>
                 </c:pt>
                 <c:pt idx="13">
+                  <c:v>0</c:v>
+                </c:pt>
+                <c:pt idx="14">
                   <c:v>195</c:v>
-                </c:pt>
-                <c:pt idx="14">
-                  <c:v>0</c:v>
                 </c:pt>
                 <c:pt idx="15">
                   <c:v>0</c:v>
@@ -2834,10 +2834,10 @@
                   <c:v>0</c:v>
                 </c:pt>
                 <c:pt idx="20">
+                  <c:v>0</c:v>
+                </c:pt>
+                <c:pt idx="21">
                   <c:v>65</c:v>
-                </c:pt>
-                <c:pt idx="21">
-                  <c:v>0</c:v>
                 </c:pt>
                 <c:pt idx="22">
                   <c:v>0</c:v>
@@ -3079,7 +3079,7 @@
                   <c:v>0</c:v>
                 </c:pt>
                 <c:pt idx="26">
-                  <c:v>58</c:v>
+                  <c:v>0</c:v>
                 </c:pt>
               </c:numCache>
             </c:numRef>
@@ -3478,7 +3478,7 @@
                   <c:v>936</c:v>
                 </c:pt>
                 <c:pt idx="7">
-                  <c:v>1040</c:v>
+                  <c:v>949</c:v>
                 </c:pt>
                 <c:pt idx="8">
                   <c:v>1053</c:v>
@@ -3496,7 +3496,7 @@
                   <c:v>1144</c:v>
                 </c:pt>
                 <c:pt idx="13">
-                  <c:v>1352</c:v>
+                  <c:v>1157</c:v>
                 </c:pt>
                 <c:pt idx="14">
                   <c:v>1365</c:v>
@@ -3517,7 +3517,7 @@
                   <c:v>1484</c:v>
                 </c:pt>
                 <c:pt idx="20">
-                  <c:v>1562</c:v>
+                  <c:v>1497</c:v>
                 </c:pt>
                 <c:pt idx="21">
                   <c:v>1575</c:v>
@@ -3535,7 +3535,7 @@
                   <c:v>1887</c:v>
                 </c:pt>
                 <c:pt idx="26">
-                  <c:v>1957</c:v>
+                  <c:v>1900</c:v>
                 </c:pt>
               </c:numCache>
             </c:numRef>
@@ -7166,14 +7166,6 @@
               </a:spcAft>
               <a:buNone/>
             </a:pPr>
-            <a:r>
-              <a:rPr lang="en-US" sz="1500" dirty="0">
-                <a:solidFill>
-                  <a:srgbClr val="222222"/>
-                </a:solidFill>
-              </a:rPr>
-              <a:t>（締切当日のみ12:00）</a:t>
-            </a:r>
             <a:endParaRPr lang="en-US" sz="1500" dirty="0"/>
           </a:p>
         </p:txBody>
@@ -9126,7 +9118,7 @@
                   <a:srgbClr val="222222"/>
                 </a:solidFill>
               </a:rPr>
-              <a:t>・27日間で計11回（</a:t>
+              <a:t>・平日のみで計10回（</a:t>
             </a:r>
             <a:pPr indent="0" marL="0">
               <a:spcAft>
@@ -9140,7 +9132,7 @@
                   <a:srgbClr val="C8102E"/>
                 </a:solidFill>
               </a:rPr>
-              <a:t>土曜は締切当日の予約投稿のみ</a:t>
+              <a:t>土日祝は投稿なし</a:t>
             </a:r>
             <a:pPr indent="0" marL="0">
               <a:spcAft>
@@ -9154,7 +9146,7 @@
                   <a:srgbClr val="222222"/>
                 </a:solidFill>
               </a:rPr>
-              <a:t>）。原則17:00、OWV公式RPは11/16・11/29・12/11</a:t>
+              <a:t>）。原則17:00、OWV公式RPは11/16・11/30・12/11の3回</a:t>
             </a:r>
             <a:endParaRPr lang="en-US" sz="1500" dirty="0"/>
           </a:p>
@@ -10721,7 +10713,7 @@
                             <a:srgbClr val="222222"/>
                           </a:solidFill>
                         </a:rPr>
-                        <a:t>11/23（月・祝）</a:t>
+                        <a:t>11/24（火）</a:t>
                       </a:r>
                       <a:endParaRPr lang="en-US" sz="1200" dirty="0"/>
                     </a:p>
@@ -10904,7 +10896,7 @@
                             <a:srgbClr val="222222"/>
                           </a:solidFill>
                         </a:rPr>
-                        <a:t>第2弾ダイジェスト公開＋次の目標</a:t>
+                        <a:t>第2弾ダイジェスト公開＋次の目標（祝日明け）</a:t>
                       </a:r>
                       <a:endParaRPr lang="en-US" sz="1200" dirty="0"/>
                     </a:p>
@@ -11433,7 +11425,7 @@
                             <a:srgbClr val="222222"/>
                           </a:solidFill>
                         </a:rPr>
-                        <a:t>11/29（日）</a:t>
+                        <a:t>11/30（月）</a:t>
                       </a:r>
                       <a:endParaRPr lang="en-US" sz="1200" dirty="0"/>
                     </a:p>
@@ -11616,7 +11608,7 @@
                             <a:srgbClr val="222222"/>
                           </a:solidFill>
                         </a:rPr>
-                        <a:t>中間の山場リマインド</a:t>
+                        <a:t>中間の山場リマインド（週明けに再点火）</a:t>
                       </a:r>
                       <a:endParaRPr lang="en-US" sz="1200" dirty="0"/>
                     </a:p>
@@ -12153,7 +12145,7 @@
                             <a:srgbClr val="222222"/>
                           </a:solidFill>
                         </a:rPr>
-                        <a:t>12/6（日）</a:t>
+                        <a:t>12/7（月）</a:t>
                       </a:r>
                       <a:endParaRPr lang="en-US" sz="1200" dirty="0"/>
                     </a:p>
@@ -12336,7 +12328,7 @@
                             <a:srgbClr val="222222"/>
                           </a:solidFill>
                         </a:rPr>
-                        <a:t>「ラスト1週間」（動画ペアの結果で時刻を見直し）</a:t>
+                        <a:t>「最終週」（動画ペアの結果で時刻を見直し）</a:t>
                       </a:r>
                       <a:endParaRPr lang="en-US" sz="1200" dirty="0"/>
                     </a:p>
@@ -13048,7 +13040,7 @@
                             <a:srgbClr val="222222"/>
                           </a:solidFill>
                         </a:rPr>
-                        <a:t>締切前日（ラストスパート）</a:t>
+                        <a:t>最終投稿「明日23:59締切」＋第4弾の公開告知</a:t>
                       </a:r>
                       <a:endParaRPr lang="en-US" sz="1200" dirty="0"/>
                     </a:p>
@@ -13206,358 +13198,6 @@
                     </a:lnB>
                     <a:solidFill>
                       <a:srgbClr val="F5F5F5"/>
-                    </a:solidFill>
-                  </a:tcPr>
-                </a:tc>
-              </a:tr>
-              <a:tr h="301752">
-                <a:tc>
-                  <a:txBody>
-                    <a:bodyPr/>
-                    <a:lstStyle/>
-                    <a:p>
-                      <a:pPr indent="0" marL="0">
-                        <a:buNone/>
-                      </a:pPr>
-                      <a:r>
-                        <a:rPr lang="en-US" sz="1200" dirty="0">
-                          <a:solidFill>
-                            <a:srgbClr val="222222"/>
-                          </a:solidFill>
-                        </a:rPr>
-                        <a:t>12/12（土）</a:t>
-                      </a:r>
-                      <a:endParaRPr lang="en-US" sz="1200" dirty="0"/>
-                    </a:p>
-                  </a:txBody>
-                  <a:tcPr marL="76200" marR="76200" marT="25400" marB="25400" anchor="ctr">
-                    <a:lnL w="6350" cap="flat" cmpd="sng" algn="ctr">
-                      <a:solidFill>
-                        <a:srgbClr val="D9D9D9"/>
-                      </a:solidFill>
-                      <a:prstDash val="solid"/>
-                      <a:round/>
-                      <a:headEnd type="none" w="med" len="med"/>
-                      <a:tailEnd type="none" w="med" len="med"/>
-                    </a:lnL>
-                    <a:lnR w="6350" cap="flat" cmpd="sng" algn="ctr">
-                      <a:solidFill>
-                        <a:srgbClr val="D9D9D9"/>
-                      </a:solidFill>
-                      <a:prstDash val="solid"/>
-                      <a:round/>
-                      <a:headEnd type="none" w="med" len="med"/>
-                      <a:tailEnd type="none" w="med" len="med"/>
-                    </a:lnR>
-                    <a:lnT w="6350" cap="flat" cmpd="sng" algn="ctr">
-                      <a:solidFill>
-                        <a:srgbClr val="D9D9D9"/>
-                      </a:solidFill>
-                      <a:prstDash val="solid"/>
-                      <a:round/>
-                      <a:headEnd type="none" w="med" len="med"/>
-                      <a:tailEnd type="none" w="med" len="med"/>
-                    </a:lnT>
-                    <a:lnB w="6350" cap="flat" cmpd="sng" algn="ctr">
-                      <a:solidFill>
-                        <a:srgbClr val="D9D9D9"/>
-                      </a:solidFill>
-                      <a:prstDash val="solid"/>
-                      <a:round/>
-                      <a:headEnd type="none" w="med" len="med"/>
-                      <a:tailEnd type="none" w="med" len="med"/>
-                    </a:lnB>
-                    <a:solidFill>
-                      <a:srgbClr val="FFFFFF"/>
-                    </a:solidFill>
-                  </a:tcPr>
-                </a:tc>
-                <a:tc>
-                  <a:txBody>
-                    <a:bodyPr/>
-                    <a:lstStyle/>
-                    <a:p>
-                      <a:pPr indent="0" marL="0">
-                        <a:buNone/>
-                      </a:pPr>
-                      <a:r>
-                        <a:rPr lang="en-US" sz="1200" dirty="0">
-                          <a:solidFill>
-                            <a:srgbClr val="222222"/>
-                          </a:solidFill>
-                        </a:rPr>
-                        <a:t>12:00</a:t>
-                      </a:r>
-                      <a:endParaRPr lang="en-US" sz="1200" dirty="0"/>
-                    </a:p>
-                  </a:txBody>
-                  <a:tcPr marL="76200" marR="76200" marT="25400" marB="25400" anchor="ctr">
-                    <a:lnL w="6350" cap="flat" cmpd="sng" algn="ctr">
-                      <a:solidFill>
-                        <a:srgbClr val="D9D9D9"/>
-                      </a:solidFill>
-                      <a:prstDash val="solid"/>
-                      <a:round/>
-                      <a:headEnd type="none" w="med" len="med"/>
-                      <a:tailEnd type="none" w="med" len="med"/>
-                    </a:lnL>
-                    <a:lnR w="6350" cap="flat" cmpd="sng" algn="ctr">
-                      <a:solidFill>
-                        <a:srgbClr val="D9D9D9"/>
-                      </a:solidFill>
-                      <a:prstDash val="solid"/>
-                      <a:round/>
-                      <a:headEnd type="none" w="med" len="med"/>
-                      <a:tailEnd type="none" w="med" len="med"/>
-                    </a:lnR>
-                    <a:lnT w="6350" cap="flat" cmpd="sng" algn="ctr">
-                      <a:solidFill>
-                        <a:srgbClr val="D9D9D9"/>
-                      </a:solidFill>
-                      <a:prstDash val="solid"/>
-                      <a:round/>
-                      <a:headEnd type="none" w="med" len="med"/>
-                      <a:tailEnd type="none" w="med" len="med"/>
-                    </a:lnT>
-                    <a:lnB w="6350" cap="flat" cmpd="sng" algn="ctr">
-                      <a:solidFill>
-                        <a:srgbClr val="D9D9D9"/>
-                      </a:solidFill>
-                      <a:prstDash val="solid"/>
-                      <a:round/>
-                      <a:headEnd type="none" w="med" len="med"/>
-                      <a:tailEnd type="none" w="med" len="med"/>
-                    </a:lnB>
-                    <a:solidFill>
-                      <a:srgbClr val="FFFFFF"/>
-                    </a:solidFill>
-                  </a:tcPr>
-                </a:tc>
-                <a:tc>
-                  <a:txBody>
-                    <a:bodyPr/>
-                    <a:lstStyle/>
-                    <a:p>
-                      <a:pPr indent="0" marL="0">
-                        <a:buNone/>
-                      </a:pPr>
-                      <a:r>
-                        <a:rPr lang="en-US" sz="1200" dirty="0">
-                          <a:solidFill>
-                            <a:srgbClr val="222222"/>
-                          </a:solidFill>
-                        </a:rPr>
-                        <a:t>予約投稿</a:t>
-                      </a:r>
-                      <a:endParaRPr lang="en-US" sz="1200" dirty="0"/>
-                    </a:p>
-                  </a:txBody>
-                  <a:tcPr marL="76200" marR="76200" marT="25400" marB="25400" anchor="ctr">
-                    <a:lnL w="6350" cap="flat" cmpd="sng" algn="ctr">
-                      <a:solidFill>
-                        <a:srgbClr val="D9D9D9"/>
-                      </a:solidFill>
-                      <a:prstDash val="solid"/>
-                      <a:round/>
-                      <a:headEnd type="none" w="med" len="med"/>
-                      <a:tailEnd type="none" w="med" len="med"/>
-                    </a:lnL>
-                    <a:lnR w="6350" cap="flat" cmpd="sng" algn="ctr">
-                      <a:solidFill>
-                        <a:srgbClr val="D9D9D9"/>
-                      </a:solidFill>
-                      <a:prstDash val="solid"/>
-                      <a:round/>
-                      <a:headEnd type="none" w="med" len="med"/>
-                      <a:tailEnd type="none" w="med" len="med"/>
-                    </a:lnR>
-                    <a:lnT w="6350" cap="flat" cmpd="sng" algn="ctr">
-                      <a:solidFill>
-                        <a:srgbClr val="D9D9D9"/>
-                      </a:solidFill>
-                      <a:prstDash val="solid"/>
-                      <a:round/>
-                      <a:headEnd type="none" w="med" len="med"/>
-                      <a:tailEnd type="none" w="med" len="med"/>
-                    </a:lnT>
-                    <a:lnB w="6350" cap="flat" cmpd="sng" algn="ctr">
-                      <a:solidFill>
-                        <a:srgbClr val="D9D9D9"/>
-                      </a:solidFill>
-                      <a:prstDash val="solid"/>
-                      <a:round/>
-                      <a:headEnd type="none" w="med" len="med"/>
-                      <a:tailEnd type="none" w="med" len="med"/>
-                    </a:lnB>
-                    <a:solidFill>
-                      <a:srgbClr val="FFFFFF"/>
-                    </a:solidFill>
-                  </a:tcPr>
-                </a:tc>
-                <a:tc>
-                  <a:txBody>
-                    <a:bodyPr/>
-                    <a:lstStyle/>
-                    <a:p>
-                      <a:pPr indent="0" marL="0">
-                        <a:buNone/>
-                      </a:pPr>
-                      <a:r>
-                        <a:rPr lang="en-US" sz="1200" dirty="0">
-                          <a:solidFill>
-                            <a:srgbClr val="222222"/>
-                          </a:solidFill>
-                        </a:rPr>
-                        <a:t>締切当日「本日23:59まで」＋第4弾公開</a:t>
-                      </a:r>
-                      <a:endParaRPr lang="en-US" sz="1200" dirty="0"/>
-                    </a:p>
-                  </a:txBody>
-                  <a:tcPr marL="76200" marR="76200" marT="25400" marB="25400" anchor="ctr">
-                    <a:lnL w="6350" cap="flat" cmpd="sng" algn="ctr">
-                      <a:solidFill>
-                        <a:srgbClr val="D9D9D9"/>
-                      </a:solidFill>
-                      <a:prstDash val="solid"/>
-                      <a:round/>
-                      <a:headEnd type="none" w="med" len="med"/>
-                      <a:tailEnd type="none" w="med" len="med"/>
-                    </a:lnL>
-                    <a:lnR w="6350" cap="flat" cmpd="sng" algn="ctr">
-                      <a:solidFill>
-                        <a:srgbClr val="D9D9D9"/>
-                      </a:solidFill>
-                      <a:prstDash val="solid"/>
-                      <a:round/>
-                      <a:headEnd type="none" w="med" len="med"/>
-                      <a:tailEnd type="none" w="med" len="med"/>
-                    </a:lnR>
-                    <a:lnT w="6350" cap="flat" cmpd="sng" algn="ctr">
-                      <a:solidFill>
-                        <a:srgbClr val="D9D9D9"/>
-                      </a:solidFill>
-                      <a:prstDash val="solid"/>
-                      <a:round/>
-                      <a:headEnd type="none" w="med" len="med"/>
-                      <a:tailEnd type="none" w="med" len="med"/>
-                    </a:lnT>
-                    <a:lnB w="6350" cap="flat" cmpd="sng" algn="ctr">
-                      <a:solidFill>
-                        <a:srgbClr val="D9D9D9"/>
-                      </a:solidFill>
-                      <a:prstDash val="solid"/>
-                      <a:round/>
-                      <a:headEnd type="none" w="med" len="med"/>
-                      <a:tailEnd type="none" w="med" len="med"/>
-                    </a:lnB>
-                    <a:solidFill>
-                      <a:srgbClr val="FFFFFF"/>
-                    </a:solidFill>
-                  </a:tcPr>
-                </a:tc>
-                <a:tc>
-                  <a:txBody>
-                    <a:bodyPr/>
-                    <a:lstStyle/>
-                    <a:p>
-                      <a:pPr algn="ctr" indent="0" marL="0">
-                        <a:buNone/>
-                      </a:pPr>
-                      <a:endParaRPr lang="en-US" sz="1200" dirty="0"/>
-                    </a:p>
-                  </a:txBody>
-                  <a:tcPr marL="76200" marR="76200" marT="25400" marB="25400" anchor="ctr">
-                    <a:lnL w="6350" cap="flat" cmpd="sng" algn="ctr">
-                      <a:solidFill>
-                        <a:srgbClr val="D9D9D9"/>
-                      </a:solidFill>
-                      <a:prstDash val="solid"/>
-                      <a:round/>
-                      <a:headEnd type="none" w="med" len="med"/>
-                      <a:tailEnd type="none" w="med" len="med"/>
-                    </a:lnL>
-                    <a:lnR w="6350" cap="flat" cmpd="sng" algn="ctr">
-                      <a:solidFill>
-                        <a:srgbClr val="D9D9D9"/>
-                      </a:solidFill>
-                      <a:prstDash val="solid"/>
-                      <a:round/>
-                      <a:headEnd type="none" w="med" len="med"/>
-                      <a:tailEnd type="none" w="med" len="med"/>
-                    </a:lnR>
-                    <a:lnT w="6350" cap="flat" cmpd="sng" algn="ctr">
-                      <a:solidFill>
-                        <a:srgbClr val="D9D9D9"/>
-                      </a:solidFill>
-                      <a:prstDash val="solid"/>
-                      <a:round/>
-                      <a:headEnd type="none" w="med" len="med"/>
-                      <a:tailEnd type="none" w="med" len="med"/>
-                    </a:lnT>
-                    <a:lnB w="6350" cap="flat" cmpd="sng" algn="ctr">
-                      <a:solidFill>
-                        <a:srgbClr val="D9D9D9"/>
-                      </a:solidFill>
-                      <a:prstDash val="solid"/>
-                      <a:round/>
-                      <a:headEnd type="none" w="med" len="med"/>
-                      <a:tailEnd type="none" w="med" len="med"/>
-                    </a:lnB>
-                    <a:solidFill>
-                      <a:srgbClr val="FFFFFF"/>
-                    </a:solidFill>
-                  </a:tcPr>
-                </a:tc>
-                <a:tc>
-                  <a:txBody>
-                    <a:bodyPr/>
-                    <a:lstStyle/>
-                    <a:p>
-                      <a:pPr algn="ctr" indent="0" marL="0">
-                        <a:buNone/>
-                      </a:pPr>
-                      <a:endParaRPr lang="en-US" sz="1200" dirty="0"/>
-                    </a:p>
-                  </a:txBody>
-                  <a:tcPr marL="76200" marR="76200" marT="25400" marB="25400" anchor="ctr">
-                    <a:lnL w="6350" cap="flat" cmpd="sng" algn="ctr">
-                      <a:solidFill>
-                        <a:srgbClr val="D9D9D9"/>
-                      </a:solidFill>
-                      <a:prstDash val="solid"/>
-                      <a:round/>
-                      <a:headEnd type="none" w="med" len="med"/>
-                      <a:tailEnd type="none" w="med" len="med"/>
-                    </a:lnL>
-                    <a:lnR w="6350" cap="flat" cmpd="sng" algn="ctr">
-                      <a:solidFill>
-                        <a:srgbClr val="D9D9D9"/>
-                      </a:solidFill>
-                      <a:prstDash val="solid"/>
-                      <a:round/>
-                      <a:headEnd type="none" w="med" len="med"/>
-                      <a:tailEnd type="none" w="med" len="med"/>
-                    </a:lnR>
-                    <a:lnT w="6350" cap="flat" cmpd="sng" algn="ctr">
-                      <a:solidFill>
-                        <a:srgbClr val="D9D9D9"/>
-                      </a:solidFill>
-                      <a:prstDash val="solid"/>
-                      <a:round/>
-                      <a:headEnd type="none" w="med" len="med"/>
-                      <a:tailEnd type="none" w="med" len="med"/>
-                    </a:lnT>
-                    <a:lnB w="6350" cap="flat" cmpd="sng" algn="ctr">
-                      <a:solidFill>
-                        <a:srgbClr val="D9D9D9"/>
-                      </a:solidFill>
-                      <a:prstDash val="solid"/>
-                      <a:round/>
-                      <a:headEnd type="none" w="med" len="med"/>
-                      <a:tailEnd type="none" w="med" len="med"/>
-                    </a:lnB>
-                    <a:solidFill>
-                      <a:srgbClr val="FFFFFF"/>
                     </a:solidFill>
                   </a:tcPr>
                 </a:tc>
@@ -13596,7 +13236,7 @@
                   <a:srgbClr val="7F7F7F"/>
                 </a:solidFill>
               </a:rPr>
-              <a:t>※11/21（土）のリマインドを削除（土曜対応不可のため）。12/12は予約投稿とし、文面は12/11夜の到達状況で確定</a:t>
+              <a:t>※土日祝（11/21・22・23・28・29、12/5・6・12）は投稿なし。12/12（土）締切のため、12/11が最終投稿</a:t>
             </a:r>
             <a:endParaRPr lang="en-US" sz="1000" dirty="0"/>
           </a:p>
@@ -13827,7 +13467,7 @@
                   <a:srgbClr val="C8102E"/>
                 </a:solidFill>
               </a:rPr>
-              <a:t>約1,960件</a:t>
+              <a:t>約1,900件</a:t>
             </a:r>
             <a:pPr indent="0" marL="0">
               <a:spcAft>
@@ -13841,7 +13481,7 @@
                   <a:srgbClr val="222222"/>
                 </a:solidFill>
               </a:rPr>
-              <a:t>（旧案：約2,130件）。12時枠の効果は17時の約6割と保守的に設定</a:t>
+              <a:t>（当初案：約2,130件）。12時枠の効果は17時の約6割と保守的に設定</a:t>
             </a:r>
             <a:endParaRPr lang="en-US" sz="1500" dirty="0"/>
           </a:p>
@@ -13858,7 +13498,7 @@
                   <a:srgbClr val="222222"/>
                 </a:solidFill>
               </a:rPr>
-              <a:t>・→ AB検証で12時の方が伸びれば上振れ。</a:t>
+              <a:t>・→ 土日祝なし・ABテスト分で</a:t>
             </a:r>
             <a:pPr indent="0" marL="0">
               <a:spcAft>
@@ -13872,7 +13512,7 @@
                   <a:srgbClr val="C8102E"/>
                 </a:solidFill>
               </a:rPr>
-              <a:t>検証の機会コストは約170件</a:t>
+              <a:t>当初案より約230件減</a:t>
             </a:r>
             <a:pPr indent="0" marL="0">
               <a:spcAft>
@@ -13886,7 +13526,7 @@
                   <a:srgbClr val="222222"/>
                 </a:solidFill>
               </a:rPr>
-              <a:t>（土曜削除の分を含む）</a:t>
+              <a:t>。12時の方が伸びれば上振れする</a:t>
             </a:r>
             <a:endParaRPr lang="en-US" sz="1500" dirty="0"/>
           </a:p>
@@ -14096,7 +13736,7 @@
                   <a:srgbClr val="222222"/>
                 </a:solidFill>
               </a:rPr>
-              <a:t>② 動画公開＝リマインド（11/19・23、12/3）</a:t>
+              <a:t>② 動画公開＝リマインド（11/19・24、12/3）</a:t>
             </a:r>
             <a:endParaRPr lang="en-US" sz="1200" dirty="0"/>
           </a:p>
@@ -14193,7 +13833,7 @@
                   <a:srgbClr val="C8102E"/>
                 </a:solidFill>
               </a:rPr>
-              <a:t>③ OWV公式RPの山場（11/16・29、12/11）</a:t>
+              <a:t>③ OWV公式RPの山場（11/16・30、12/11）</a:t>
             </a:r>
             <a:endParaRPr lang="en-US" sz="1200" dirty="0"/>
           </a:p>
@@ -14290,7 +13930,7 @@
                   <a:srgbClr val="222222"/>
                 </a:solidFill>
               </a:rPr>
-              <a:t>④ 締切前の駆け込み（12/6・10・11・12）</a:t>
+              <a:t>④ 締切前の駆け込み（12/7・10・11）</a:t>
             </a:r>
             <a:endParaRPr lang="en-US" sz="1200" dirty="0"/>
           </a:p>
@@ -14362,7 +14002,7 @@
                   <a:srgbClr val="7F7F7F"/>
                 </a:solidFill>
               </a:rPr>
-              <a:t>※試算前提：初日650件（井上実績×1.3）→初日比8%・4%・2%で減衰。上乗せ：リマインド10%・動画公開14%・OWV公式RP30%・締切当日15%、12時投稿は×0.59</a:t>
+              <a:t>※試算前提：初日650件（井上実績×1.3）→初日比8%・4%・2%で減衰。上乗せ：リマインド10%・動画公開14%・OWV公式RP30%、12時投稿は×0.59</a:t>
             </a:r>
             <a:endParaRPr lang="en-US" sz="1000" dirty="0"/>
           </a:p>
@@ -14621,7 +14261,7 @@
                   <a:srgbClr val="C8102E"/>
                 </a:solidFill>
               </a:rPr>
-              <a:t>締切時点で約1,960件（2,000件はストレッチ）</a:t>
+              <a:t>締切時点で約1,900件（2,000件はストレッチ）</a:t>
             </a:r>
             <a:endParaRPr lang="en-US" sz="1500" dirty="0"/>
           </a:p>
@@ -15801,7 +15441,7 @@
                             <a:srgbClr val="222222"/>
                           </a:solidFill>
                         </a:rPr>
-                        <a:t>11/29</a:t>
+                        <a:t>11/30</a:t>
                       </a:r>
                       <a:endParaRPr lang="en-US" sz="1100" dirty="0"/>
                     </a:p>
@@ -15986,7 +15626,7 @@
                             <a:srgbClr val="222222"/>
                           </a:solidFill>
                         </a:rPr>
-                        <a:t>OWV公式RP＋締切の駆け込み</a:t>
+                        <a:t>OWV公式RP＋締切前の駆け込み</a:t>
                       </a:r>
                       <a:endParaRPr lang="en-US" sz="1100" dirty="0"/>
                     </a:p>
@@ -16047,7 +15687,7 @@
                             <a:srgbClr val="C8102E"/>
                           </a:solidFill>
                         </a:rPr>
-                        <a:t>締切前後</a:t>
+                        <a:t>未達の恐れ</a:t>
                       </a:r>
                       <a:endParaRPr lang="en-US" sz="1100" dirty="0"/>
                     </a:p>

</xml_diff>